<commit_message>
L06 shiz? May break everything lmfao
</commit_message>
<xml_diff>
--- a/Blank/Lecture_05_ Tokenization_03.pptx
+++ b/Blank/Lecture_05_ Tokenization_03.pptx
@@ -267,7 +267,7 @@
   </p:defaultTextStyle>
   <p:extLst>
     <p:ext uri="GoogleSlidesCustomDataVersion2">
-      <go:slidesCustomData xmlns:go="http://customooxmlschemas.google.com/" r:id="rId30" roundtripDataSignature="AMtx7mi4T2+YXSeykhj9D+Gkhd3lghAE0Q=="/>
+      <go:slidesCustomData xmlns:go="http://customooxmlschemas.google.com/" r:id="rId30" roundtripDataSignature="AMtx7mjBcaVylMX+7tKAflK6s1IQ3s5NzQ=="/>
     </p:ext>
   </p:extLst>
 </p:presentation>
@@ -1523,7 +1523,7 @@
   <p:cSld>
     <p:spTree>
       <p:nvGrpSpPr>
-        <p:cNvPr id="160" name="Shape 160"/>
+        <p:cNvPr id="166" name="Shape 166"/>
         <p:cNvGrpSpPr/>
         <p:nvPr/>
       </p:nvGrpSpPr>
@@ -1537,7 +1537,7 @@
       </p:grpSpPr>
       <p:sp>
         <p:nvSpPr>
-          <p:cNvPr id="161" name="Google Shape;161;g3b8409de4d6_0_108:notes"/>
+          <p:cNvPr id="167" name="Google Shape;167;g3b8409de4d6_0_108:notes"/>
           <p:cNvSpPr/>
           <p:nvPr>
             <p:ph idx="2" type="sldImg"/>
@@ -1582,7 +1582,7 @@
       </p:sp>
       <p:sp>
         <p:nvSpPr>
-          <p:cNvPr id="162" name="Google Shape;162;g3b8409de4d6_0_108:notes"/>
+          <p:cNvPr id="168" name="Google Shape;168;g3b8409de4d6_0_108:notes"/>
           <p:cNvSpPr txBox="1"/>
           <p:nvPr>
             <p:ph idx="1" type="body"/>
@@ -1640,7 +1640,7 @@
   <p:cSld>
     <p:spTree>
       <p:nvGrpSpPr>
-        <p:cNvPr id="168" name="Shape 168"/>
+        <p:cNvPr id="174" name="Shape 174"/>
         <p:cNvGrpSpPr/>
         <p:nvPr/>
       </p:nvGrpSpPr>
@@ -1654,7 +1654,7 @@
       </p:grpSpPr>
       <p:sp>
         <p:nvSpPr>
-          <p:cNvPr id="169" name="Google Shape;169;g3bbeee67e43_0_26:notes"/>
+          <p:cNvPr id="175" name="Google Shape;175;g3bbeee67e43_0_26:notes"/>
           <p:cNvSpPr/>
           <p:nvPr>
             <p:ph idx="2" type="sldImg"/>
@@ -1699,7 +1699,7 @@
       </p:sp>
       <p:sp>
         <p:nvSpPr>
-          <p:cNvPr id="170" name="Google Shape;170;g3bbeee67e43_0_26:notes"/>
+          <p:cNvPr id="176" name="Google Shape;176;g3bbeee67e43_0_26:notes"/>
           <p:cNvSpPr txBox="1"/>
           <p:nvPr>
             <p:ph idx="1" type="body"/>
@@ -1757,7 +1757,7 @@
   <p:cSld>
     <p:spTree>
       <p:nvGrpSpPr>
-        <p:cNvPr id="173" name="Shape 173"/>
+        <p:cNvPr id="179" name="Shape 179"/>
         <p:cNvGrpSpPr/>
         <p:nvPr/>
       </p:nvGrpSpPr>
@@ -1771,7 +1771,7 @@
       </p:grpSpPr>
       <p:sp>
         <p:nvSpPr>
-          <p:cNvPr id="174" name="Google Shape;174;g3bbeee67e43_0_44:notes"/>
+          <p:cNvPr id="180" name="Google Shape;180;g3bbeee67e43_0_44:notes"/>
           <p:cNvSpPr/>
           <p:nvPr>
             <p:ph idx="2" type="sldImg"/>
@@ -1806,7 +1806,7 @@
       </p:sp>
       <p:sp>
         <p:nvSpPr>
-          <p:cNvPr id="175" name="Google Shape;175;g3bbeee67e43_0_44:notes"/>
+          <p:cNvPr id="181" name="Google Shape;181;g3bbeee67e43_0_44:notes"/>
           <p:cNvSpPr txBox="1"/>
           <p:nvPr>
             <p:ph idx="1" type="body"/>
@@ -1856,7 +1856,7 @@
   <p:cSld>
     <p:spTree>
       <p:nvGrpSpPr>
-        <p:cNvPr id="181" name="Shape 181"/>
+        <p:cNvPr id="187" name="Shape 187"/>
         <p:cNvGrpSpPr/>
         <p:nvPr/>
       </p:nvGrpSpPr>
@@ -1870,7 +1870,7 @@
       </p:grpSpPr>
       <p:sp>
         <p:nvSpPr>
-          <p:cNvPr id="182" name="Google Shape;182;g3bbeee67e43_0_53:notes"/>
+          <p:cNvPr id="188" name="Google Shape;188;g3bbeee67e43_0_53:notes"/>
           <p:cNvSpPr/>
           <p:nvPr>
             <p:ph idx="2" type="sldImg"/>
@@ -1905,7 +1905,7 @@
       </p:sp>
       <p:sp>
         <p:nvSpPr>
-          <p:cNvPr id="183" name="Google Shape;183;g3bbeee67e43_0_53:notes"/>
+          <p:cNvPr id="189" name="Google Shape;189;g3bbeee67e43_0_53:notes"/>
           <p:cNvSpPr txBox="1"/>
           <p:nvPr>
             <p:ph idx="1" type="body"/>
@@ -1955,7 +1955,7 @@
   <p:cSld>
     <p:spTree>
       <p:nvGrpSpPr>
-        <p:cNvPr id="203" name="Shape 203"/>
+        <p:cNvPr id="209" name="Shape 209"/>
         <p:cNvGrpSpPr/>
         <p:nvPr/>
       </p:nvGrpSpPr>
@@ -1969,7 +1969,7 @@
       </p:grpSpPr>
       <p:sp>
         <p:nvSpPr>
-          <p:cNvPr id="204" name="Google Shape;204;g3bbeee67e43_0_98:notes"/>
+          <p:cNvPr id="210" name="Google Shape;210;g3bbeee67e43_0_98:notes"/>
           <p:cNvSpPr/>
           <p:nvPr>
             <p:ph idx="2" type="sldImg"/>
@@ -2004,7 +2004,7 @@
       </p:sp>
       <p:sp>
         <p:nvSpPr>
-          <p:cNvPr id="205" name="Google Shape;205;g3bbeee67e43_0_98:notes"/>
+          <p:cNvPr id="211" name="Google Shape;211;g3bbeee67e43_0_98:notes"/>
           <p:cNvSpPr txBox="1"/>
           <p:nvPr>
             <p:ph idx="1" type="body"/>
@@ -2171,7 +2171,7 @@
   <p:cSld>
     <p:spTree>
       <p:nvGrpSpPr>
-        <p:cNvPr id="209" name="Shape 209"/>
+        <p:cNvPr id="215" name="Shape 215"/>
         <p:cNvGrpSpPr/>
         <p:nvPr/>
       </p:nvGrpSpPr>
@@ -2185,7 +2185,7 @@
       </p:grpSpPr>
       <p:sp>
         <p:nvSpPr>
-          <p:cNvPr id="210" name="Google Shape;210;g3bbeee67e43_0_137:notes"/>
+          <p:cNvPr id="216" name="Google Shape;216;g3bbeee67e43_0_137:notes"/>
           <p:cNvSpPr/>
           <p:nvPr>
             <p:ph idx="2" type="sldImg"/>
@@ -2230,7 +2230,7 @@
       </p:sp>
       <p:sp>
         <p:nvSpPr>
-          <p:cNvPr id="211" name="Google Shape;211;g3bbeee67e43_0_137:notes"/>
+          <p:cNvPr id="217" name="Google Shape;217;g3bbeee67e43_0_137:notes"/>
           <p:cNvSpPr txBox="1"/>
           <p:nvPr>
             <p:ph idx="1" type="body"/>
@@ -2288,7 +2288,7 @@
   <p:cSld>
     <p:spTree>
       <p:nvGrpSpPr>
-        <p:cNvPr id="215" name="Shape 215"/>
+        <p:cNvPr id="221" name="Shape 221"/>
         <p:cNvGrpSpPr/>
         <p:nvPr/>
       </p:nvGrpSpPr>
@@ -2302,7 +2302,7 @@
       </p:grpSpPr>
       <p:sp>
         <p:nvSpPr>
-          <p:cNvPr id="216" name="Google Shape;216;g3bbeee67e43_0_126:notes"/>
+          <p:cNvPr id="222" name="Google Shape;222;g3bbeee67e43_0_126:notes"/>
           <p:cNvSpPr/>
           <p:nvPr>
             <p:ph idx="2" type="sldImg"/>
@@ -2347,7 +2347,7 @@
       </p:sp>
       <p:sp>
         <p:nvSpPr>
-          <p:cNvPr id="217" name="Google Shape;217;g3bbeee67e43_0_126:notes"/>
+          <p:cNvPr id="223" name="Google Shape;223;g3bbeee67e43_0_126:notes"/>
           <p:cNvSpPr txBox="1"/>
           <p:nvPr>
             <p:ph idx="1" type="body"/>
@@ -2405,7 +2405,7 @@
   <p:cSld>
     <p:spTree>
       <p:nvGrpSpPr>
-        <p:cNvPr id="221" name="Shape 221"/>
+        <p:cNvPr id="227" name="Shape 227"/>
         <p:cNvGrpSpPr/>
         <p:nvPr/>
       </p:nvGrpSpPr>
@@ -2419,7 +2419,7 @@
       </p:grpSpPr>
       <p:sp>
         <p:nvSpPr>
-          <p:cNvPr id="222" name="Google Shape;222;g3bbeee67e43_0_132:notes"/>
+          <p:cNvPr id="228" name="Google Shape;228;g3bbeee67e43_0_132:notes"/>
           <p:cNvSpPr/>
           <p:nvPr>
             <p:ph idx="2" type="sldImg"/>
@@ -2464,7 +2464,7 @@
       </p:sp>
       <p:sp>
         <p:nvSpPr>
-          <p:cNvPr id="223" name="Google Shape;223;g3bbeee67e43_0_132:notes"/>
+          <p:cNvPr id="229" name="Google Shape;229;g3bbeee67e43_0_132:notes"/>
           <p:cNvSpPr txBox="1"/>
           <p:nvPr>
             <p:ph idx="1" type="body"/>
@@ -2522,7 +2522,7 @@
   <p:cSld>
     <p:spTree>
       <p:nvGrpSpPr>
-        <p:cNvPr id="227" name="Shape 227"/>
+        <p:cNvPr id="233" name="Shape 233"/>
         <p:cNvGrpSpPr/>
         <p:nvPr/>
       </p:nvGrpSpPr>
@@ -2536,7 +2536,7 @@
       </p:grpSpPr>
       <p:sp>
         <p:nvSpPr>
-          <p:cNvPr id="228" name="Google Shape;228;g3bbeee67e43_0_147:notes"/>
+          <p:cNvPr id="234" name="Google Shape;234;g3bbeee67e43_0_147:notes"/>
           <p:cNvSpPr/>
           <p:nvPr>
             <p:ph idx="2" type="sldImg"/>
@@ -2581,7 +2581,7 @@
       </p:sp>
       <p:sp>
         <p:nvSpPr>
-          <p:cNvPr id="229" name="Google Shape;229;g3bbeee67e43_0_147:notes"/>
+          <p:cNvPr id="235" name="Google Shape;235;g3bbeee67e43_0_147:notes"/>
           <p:cNvSpPr txBox="1"/>
           <p:nvPr>
             <p:ph idx="1" type="body"/>
@@ -2639,7 +2639,7 @@
   <p:cSld>
     <p:spTree>
       <p:nvGrpSpPr>
-        <p:cNvPr id="233" name="Shape 233"/>
+        <p:cNvPr id="239" name="Shape 239"/>
         <p:cNvGrpSpPr/>
         <p:nvPr/>
       </p:nvGrpSpPr>
@@ -2653,7 +2653,7 @@
       </p:grpSpPr>
       <p:sp>
         <p:nvSpPr>
-          <p:cNvPr id="234" name="Google Shape;234;g3bbeee67e43_0_142:notes"/>
+          <p:cNvPr id="240" name="Google Shape;240;g3bbeee67e43_0_142:notes"/>
           <p:cNvSpPr/>
           <p:nvPr>
             <p:ph idx="2" type="sldImg"/>
@@ -2698,7 +2698,7 @@
       </p:sp>
       <p:sp>
         <p:nvSpPr>
-          <p:cNvPr id="235" name="Google Shape;235;g3bbeee67e43_0_142:notes"/>
+          <p:cNvPr id="241" name="Google Shape;241;g3bbeee67e43_0_142:notes"/>
           <p:cNvSpPr txBox="1"/>
           <p:nvPr>
             <p:ph idx="1" type="body"/>
@@ -2756,7 +2756,7 @@
   <p:cSld>
     <p:spTree>
       <p:nvGrpSpPr>
-        <p:cNvPr id="239" name="Shape 239"/>
+        <p:cNvPr id="245" name="Shape 245"/>
         <p:cNvGrpSpPr/>
         <p:nvPr/>
       </p:nvGrpSpPr>
@@ -2770,7 +2770,7 @@
       </p:grpSpPr>
       <p:sp>
         <p:nvSpPr>
-          <p:cNvPr id="240" name="Google Shape;240;g3bbeee67e43_0_93:notes"/>
+          <p:cNvPr id="246" name="Google Shape;246;g3bbeee67e43_0_93:notes"/>
           <p:cNvSpPr/>
           <p:nvPr>
             <p:ph idx="2" type="sldImg"/>
@@ -2805,7 +2805,7 @@
       </p:sp>
       <p:sp>
         <p:nvSpPr>
-          <p:cNvPr id="241" name="Google Shape;241;g3bbeee67e43_0_93:notes"/>
+          <p:cNvPr id="247" name="Google Shape;247;g3bbeee67e43_0_93:notes"/>
           <p:cNvSpPr txBox="1"/>
           <p:nvPr>
             <p:ph idx="1" type="body"/>
@@ -10799,7 +10799,19 @@
                 <a:cs typeface="Consolas"/>
                 <a:sym typeface="Consolas"/>
               </a:rPr>
-              <a:t>lab 01</a:t>
+              <a:t>L</a:t>
+            </a:r>
+            <a:r>
+              <a:rPr lang="en">
+                <a:solidFill>
+                  <a:srgbClr val="DCB439"/>
+                </a:solidFill>
+                <a:latin typeface="Consolas"/>
+                <a:ea typeface="Consolas"/>
+                <a:cs typeface="Consolas"/>
+                <a:sym typeface="Consolas"/>
+              </a:rPr>
+              <a:t>ab 01</a:t>
             </a:r>
             <a:endParaRPr>
               <a:solidFill>
@@ -12062,6 +12074,318 @@
           </a:ln>
         </p:spPr>
       </p:cxnSp>
+      <p:sp>
+        <p:nvSpPr>
+          <p:cNvPr id="160" name="Google Shape;160;g3bbeee67e43_0_30"/>
+          <p:cNvSpPr/>
+          <p:nvPr/>
+        </p:nvSpPr>
+        <p:spPr>
+          <a:xfrm>
+            <a:off x="3277225" y="5186563"/>
+            <a:ext cx="678300" cy="226800"/>
+          </a:xfrm>
+          <a:prstGeom prst="rect">
+            <a:avLst/>
+          </a:prstGeom>
+          <a:noFill/>
+          <a:ln cap="flat" cmpd="sng" w="38100">
+            <a:solidFill>
+              <a:srgbClr val="A31515"/>
+            </a:solidFill>
+            <a:prstDash val="solid"/>
+            <a:round/>
+            <a:headEnd len="sm" w="sm" type="none"/>
+            <a:tailEnd len="sm" w="sm" type="none"/>
+          </a:ln>
+        </p:spPr>
+        <p:txBody>
+          <a:bodyPr anchorCtr="0" anchor="ctr" bIns="40675" lIns="40675" spcFirstLastPara="1" rIns="40675" wrap="square" tIns="40675">
+            <a:noAutofit/>
+          </a:bodyPr>
+          <a:lstStyle/>
+          <a:p>
+            <a:pPr indent="0" lvl="0" marL="0" marR="0" rtl="0" algn="ctr">
+              <a:lnSpc>
+                <a:spcPct val="100000"/>
+              </a:lnSpc>
+              <a:spcBef>
+                <a:spcPts val="0"/>
+              </a:spcBef>
+              <a:spcAft>
+                <a:spcPts val="0"/>
+              </a:spcAft>
+              <a:buClr>
+                <a:srgbClr val="000000"/>
+              </a:buClr>
+              <a:buSzPts val="623"/>
+              <a:buFont typeface="Arial"/>
+              <a:buNone/>
+            </a:pPr>
+            <a:r>
+              <a:t/>
+            </a:r>
+            <a:endParaRPr b="0" i="0" sz="622" u="none" cap="none" strike="noStrike">
+              <a:solidFill>
+                <a:srgbClr val="DCB439"/>
+              </a:solidFill>
+              <a:latin typeface="Arial"/>
+              <a:ea typeface="Arial"/>
+              <a:cs typeface="Arial"/>
+              <a:sym typeface="Arial"/>
+            </a:endParaRPr>
+          </a:p>
+        </p:txBody>
+      </p:sp>
+      <p:sp>
+        <p:nvSpPr>
+          <p:cNvPr id="161" name="Google Shape;161;g3bbeee67e43_0_30"/>
+          <p:cNvSpPr txBox="1"/>
+          <p:nvPr/>
+        </p:nvSpPr>
+        <p:spPr>
+          <a:xfrm>
+            <a:off x="2086125" y="5186563"/>
+            <a:ext cx="725400" cy="226800"/>
+          </a:xfrm>
+          <a:prstGeom prst="rect">
+            <a:avLst/>
+          </a:prstGeom>
+          <a:noFill/>
+          <a:ln cap="flat" cmpd="sng" w="38100">
+            <a:solidFill>
+              <a:srgbClr val="A31515"/>
+            </a:solidFill>
+            <a:prstDash val="solid"/>
+            <a:round/>
+            <a:headEnd len="sm" w="sm" type="none"/>
+            <a:tailEnd len="sm" w="sm" type="none"/>
+          </a:ln>
+        </p:spPr>
+        <p:txBody>
+          <a:bodyPr anchorCtr="0" anchor="ctr" bIns="91425" lIns="91425" spcFirstLastPara="1" rIns="91425" wrap="square" tIns="91425">
+            <a:noAutofit/>
+          </a:bodyPr>
+          <a:lstStyle/>
+          <a:p>
+            <a:pPr indent="0" lvl="0" marL="0" rtl="0" algn="ctr">
+              <a:spcBef>
+                <a:spcPts val="0"/>
+              </a:spcBef>
+              <a:spcAft>
+                <a:spcPts val="0"/>
+              </a:spcAft>
+              <a:buNone/>
+            </a:pPr>
+            <a:r>
+              <a:rPr b="1" lang="en" sz="1200">
+                <a:solidFill>
+                  <a:srgbClr val="DCB439"/>
+                </a:solidFill>
+                <a:latin typeface="Consolas"/>
+                <a:ea typeface="Consolas"/>
+                <a:cs typeface="Consolas"/>
+                <a:sym typeface="Consolas"/>
+              </a:rPr>
+              <a:t>Lab 04</a:t>
+            </a:r>
+            <a:endParaRPr b="1" sz="1200">
+              <a:solidFill>
+                <a:srgbClr val="DCB439"/>
+              </a:solidFill>
+              <a:latin typeface="Consolas"/>
+              <a:ea typeface="Consolas"/>
+              <a:cs typeface="Consolas"/>
+              <a:sym typeface="Consolas"/>
+            </a:endParaRPr>
+          </a:p>
+        </p:txBody>
+      </p:sp>
+      <p:cxnSp>
+        <p:nvCxnSpPr>
+          <p:cNvPr id="162" name="Google Shape;162;g3bbeee67e43_0_30"/>
+          <p:cNvCxnSpPr>
+            <a:stCxn id="161" idx="3"/>
+            <a:endCxn id="160" idx="1"/>
+          </p:cNvCxnSpPr>
+          <p:nvPr/>
+        </p:nvCxnSpPr>
+        <p:spPr>
+          <a:xfrm>
+            <a:off x="2811525" y="5299963"/>
+            <a:ext cx="465600" cy="0"/>
+          </a:xfrm>
+          <a:prstGeom prst="straightConnector1">
+            <a:avLst/>
+          </a:prstGeom>
+          <a:noFill/>
+          <a:ln cap="flat" cmpd="sng" w="19050">
+            <a:solidFill>
+              <a:srgbClr val="A31515"/>
+            </a:solidFill>
+            <a:prstDash val="solid"/>
+            <a:round/>
+            <a:headEnd len="med" w="med" type="none"/>
+            <a:tailEnd len="med" w="med" type="none"/>
+          </a:ln>
+        </p:spPr>
+      </p:cxnSp>
+      <p:sp>
+        <p:nvSpPr>
+          <p:cNvPr id="163" name="Google Shape;163;g3bbeee67e43_0_30"/>
+          <p:cNvSpPr/>
+          <p:nvPr/>
+        </p:nvSpPr>
+        <p:spPr>
+          <a:xfrm>
+            <a:off x="2946125" y="3766950"/>
+            <a:ext cx="1375500" cy="415800"/>
+          </a:xfrm>
+          <a:prstGeom prst="rect">
+            <a:avLst/>
+          </a:prstGeom>
+          <a:noFill/>
+          <a:ln cap="flat" cmpd="sng" w="38100">
+            <a:solidFill>
+              <a:srgbClr val="A31515"/>
+            </a:solidFill>
+            <a:prstDash val="solid"/>
+            <a:round/>
+            <a:headEnd len="sm" w="sm" type="none"/>
+            <a:tailEnd len="sm" w="sm" type="none"/>
+          </a:ln>
+        </p:spPr>
+        <p:txBody>
+          <a:bodyPr anchorCtr="0" anchor="ctr" bIns="40675" lIns="40675" spcFirstLastPara="1" rIns="40675" wrap="square" tIns="40675">
+            <a:noAutofit/>
+          </a:bodyPr>
+          <a:lstStyle/>
+          <a:p>
+            <a:pPr indent="0" lvl="0" marL="0" marR="0" rtl="0" algn="ctr">
+              <a:lnSpc>
+                <a:spcPct val="100000"/>
+              </a:lnSpc>
+              <a:spcBef>
+                <a:spcPts val="0"/>
+              </a:spcBef>
+              <a:spcAft>
+                <a:spcPts val="0"/>
+              </a:spcAft>
+              <a:buClr>
+                <a:srgbClr val="000000"/>
+              </a:buClr>
+              <a:buSzPts val="623"/>
+              <a:buFont typeface="Arial"/>
+              <a:buNone/>
+            </a:pPr>
+            <a:r>
+              <a:t/>
+            </a:r>
+            <a:endParaRPr b="0" i="0" sz="622" u="none" cap="none" strike="noStrike">
+              <a:solidFill>
+                <a:srgbClr val="DCB439"/>
+              </a:solidFill>
+              <a:latin typeface="Arial"/>
+              <a:ea typeface="Arial"/>
+              <a:cs typeface="Arial"/>
+              <a:sym typeface="Arial"/>
+            </a:endParaRPr>
+          </a:p>
+        </p:txBody>
+      </p:sp>
+      <p:sp>
+        <p:nvSpPr>
+          <p:cNvPr id="164" name="Google Shape;164;g3bbeee67e43_0_30"/>
+          <p:cNvSpPr txBox="1"/>
+          <p:nvPr/>
+        </p:nvSpPr>
+        <p:spPr>
+          <a:xfrm>
+            <a:off x="1949775" y="3861450"/>
+            <a:ext cx="725400" cy="226800"/>
+          </a:xfrm>
+          <a:prstGeom prst="rect">
+            <a:avLst/>
+          </a:prstGeom>
+          <a:noFill/>
+          <a:ln cap="flat" cmpd="sng" w="38100">
+            <a:solidFill>
+              <a:srgbClr val="A31515"/>
+            </a:solidFill>
+            <a:prstDash val="solid"/>
+            <a:round/>
+            <a:headEnd len="sm" w="sm" type="none"/>
+            <a:tailEnd len="sm" w="sm" type="none"/>
+          </a:ln>
+        </p:spPr>
+        <p:txBody>
+          <a:bodyPr anchorCtr="0" anchor="ctr" bIns="91425" lIns="91425" spcFirstLastPara="1" rIns="91425" wrap="square" tIns="91425">
+            <a:noAutofit/>
+          </a:bodyPr>
+          <a:lstStyle/>
+          <a:p>
+            <a:pPr indent="0" lvl="0" marL="0" rtl="0" algn="ctr">
+              <a:spcBef>
+                <a:spcPts val="0"/>
+              </a:spcBef>
+              <a:spcAft>
+                <a:spcPts val="0"/>
+              </a:spcAft>
+              <a:buNone/>
+            </a:pPr>
+            <a:r>
+              <a:rPr b="1" lang="en" sz="1200">
+                <a:solidFill>
+                  <a:srgbClr val="DCB439"/>
+                </a:solidFill>
+                <a:latin typeface="Consolas"/>
+                <a:ea typeface="Consolas"/>
+                <a:cs typeface="Consolas"/>
+                <a:sym typeface="Consolas"/>
+              </a:rPr>
+              <a:t>Lab 05</a:t>
+            </a:r>
+            <a:endParaRPr b="1" sz="1200">
+              <a:solidFill>
+                <a:srgbClr val="DCB439"/>
+              </a:solidFill>
+              <a:latin typeface="Consolas"/>
+              <a:ea typeface="Consolas"/>
+              <a:cs typeface="Consolas"/>
+              <a:sym typeface="Consolas"/>
+            </a:endParaRPr>
+          </a:p>
+        </p:txBody>
+      </p:sp>
+      <p:cxnSp>
+        <p:nvCxnSpPr>
+          <p:cNvPr id="165" name="Google Shape;165;g3bbeee67e43_0_30"/>
+          <p:cNvCxnSpPr>
+            <a:stCxn id="164" idx="3"/>
+            <a:endCxn id="163" idx="1"/>
+          </p:cNvCxnSpPr>
+          <p:nvPr/>
+        </p:nvCxnSpPr>
+        <p:spPr>
+          <a:xfrm>
+            <a:off x="2675175" y="3974850"/>
+            <a:ext cx="270900" cy="0"/>
+          </a:xfrm>
+          <a:prstGeom prst="straightConnector1">
+            <a:avLst/>
+          </a:prstGeom>
+          <a:noFill/>
+          <a:ln cap="flat" cmpd="sng" w="19050">
+            <a:solidFill>
+              <a:srgbClr val="A31515"/>
+            </a:solidFill>
+            <a:prstDash val="solid"/>
+            <a:round/>
+            <a:headEnd len="med" w="med" type="none"/>
+            <a:tailEnd len="med" w="med" type="none"/>
+          </a:ln>
+        </p:spPr>
+      </p:cxnSp>
     </p:spTree>
   </p:cSld>
   <p:clrMapOvr>
@@ -12075,7 +12399,7 @@
   <p:cSld>
     <p:spTree>
       <p:nvGrpSpPr>
-        <p:cNvPr id="163" name="Shape 163"/>
+        <p:cNvPr id="169" name="Shape 169"/>
         <p:cNvGrpSpPr/>
         <p:nvPr/>
       </p:nvGrpSpPr>
@@ -12089,7 +12413,7 @@
       </p:grpSpPr>
       <p:sp>
         <p:nvSpPr>
-          <p:cNvPr id="164" name="Google Shape;164;g3b8409de4d6_0_108"/>
+          <p:cNvPr id="170" name="Google Shape;170;g3b8409de4d6_0_108"/>
           <p:cNvSpPr txBox="1"/>
           <p:nvPr>
             <p:ph type="title"/>
@@ -12137,7 +12461,7 @@
       </p:sp>
       <p:sp>
         <p:nvSpPr>
-          <p:cNvPr id="165" name="Google Shape;165;g3b8409de4d6_0_108"/>
+          <p:cNvPr id="171" name="Google Shape;171;g3b8409de4d6_0_108"/>
           <p:cNvSpPr txBox="1"/>
           <p:nvPr>
             <p:ph idx="1" type="body"/>
@@ -12285,7 +12609,7 @@
       </p:sp>
       <p:pic>
         <p:nvPicPr>
-          <p:cNvPr id="166" name="Google Shape;166;g3b8409de4d6_0_108"/>
+          <p:cNvPr id="172" name="Google Shape;172;g3b8409de4d6_0_108"/>
           <p:cNvPicPr preferRelativeResize="0"/>
           <p:nvPr/>
         </p:nvPicPr>
@@ -12312,7 +12636,7 @@
       </p:pic>
       <p:pic>
         <p:nvPicPr>
-          <p:cNvPr id="167" name="Google Shape;167;g3b8409de4d6_0_108" title="IMG_0529.jpeg"/>
+          <p:cNvPr id="173" name="Google Shape;173;g3b8409de4d6_0_108" title="IMG_0529.jpeg"/>
           <p:cNvPicPr preferRelativeResize="0"/>
           <p:nvPr/>
         </p:nvPicPr>
@@ -12350,7 +12674,7 @@
   <p:cSld>
     <p:spTree>
       <p:nvGrpSpPr>
-        <p:cNvPr id="171" name="Shape 171"/>
+        <p:cNvPr id="177" name="Shape 177"/>
         <p:cNvGrpSpPr/>
         <p:nvPr/>
       </p:nvGrpSpPr>
@@ -12364,7 +12688,7 @@
       </p:grpSpPr>
       <p:sp>
         <p:nvSpPr>
-          <p:cNvPr id="172" name="Google Shape;172;g3bbeee67e43_0_26"/>
+          <p:cNvPr id="178" name="Google Shape;178;g3bbeee67e43_0_26"/>
           <p:cNvSpPr txBox="1"/>
           <p:nvPr>
             <p:ph type="ctrTitle"/>
@@ -12466,7 +12790,7 @@
   <p:cSld>
     <p:spTree>
       <p:nvGrpSpPr>
-        <p:cNvPr id="176" name="Shape 176"/>
+        <p:cNvPr id="182" name="Shape 182"/>
         <p:cNvGrpSpPr/>
         <p:nvPr/>
       </p:nvGrpSpPr>
@@ -12480,7 +12804,7 @@
       </p:grpSpPr>
       <p:sp>
         <p:nvSpPr>
-          <p:cNvPr id="177" name="Google Shape;177;g3bbeee67e43_0_44"/>
+          <p:cNvPr id="183" name="Google Shape;183;g3bbeee67e43_0_44"/>
           <p:cNvSpPr txBox="1"/>
           <p:nvPr>
             <p:ph type="title"/>
@@ -12520,7 +12844,7 @@
       </p:sp>
       <p:sp>
         <p:nvSpPr>
-          <p:cNvPr id="178" name="Google Shape;178;g3bbeee67e43_0_44"/>
+          <p:cNvPr id="184" name="Google Shape;184;g3bbeee67e43_0_44"/>
           <p:cNvSpPr txBox="1"/>
           <p:nvPr>
             <p:ph idx="1" type="body"/>
@@ -12568,7 +12892,7 @@
       </p:sp>
       <p:pic>
         <p:nvPicPr>
-          <p:cNvPr id="179" name="Google Shape;179;g3bbeee67e43_0_44" title="Screenshot 2026-01-27 at 11.03.21 AM.png"/>
+          <p:cNvPr id="185" name="Google Shape;185;g3bbeee67e43_0_44" title="Screenshot 2026-01-27 at 11.03.21 AM.png"/>
           <p:cNvPicPr preferRelativeResize="0"/>
           <p:nvPr/>
         </p:nvPicPr>
@@ -12596,7 +12920,7 @@
       </p:pic>
       <p:pic>
         <p:nvPicPr>
-          <p:cNvPr id="180" name="Google Shape;180;g3bbeee67e43_0_44" title="Screenshot 2026-01-27 at 11.04.18 AM.png"/>
+          <p:cNvPr id="186" name="Google Shape;186;g3bbeee67e43_0_44" title="Screenshot 2026-01-27 at 11.04.18 AM.png"/>
           <p:cNvPicPr preferRelativeResize="0"/>
           <p:nvPr/>
         </p:nvPicPr>
@@ -12635,7 +12959,7 @@
   <p:cSld>
     <p:spTree>
       <p:nvGrpSpPr>
-        <p:cNvPr id="184" name="Shape 184"/>
+        <p:cNvPr id="190" name="Shape 190"/>
         <p:cNvGrpSpPr/>
         <p:nvPr/>
       </p:nvGrpSpPr>
@@ -12649,7 +12973,7 @@
       </p:grpSpPr>
       <p:sp>
         <p:nvSpPr>
-          <p:cNvPr id="185" name="Google Shape;185;g3bbeee67e43_0_53"/>
+          <p:cNvPr id="191" name="Google Shape;191;g3bbeee67e43_0_53"/>
           <p:cNvSpPr txBox="1"/>
           <p:nvPr>
             <p:ph type="title"/>
@@ -12689,7 +13013,7 @@
       </p:sp>
       <p:pic>
         <p:nvPicPr>
-          <p:cNvPr id="186" name="Google Shape;186;g3bbeee67e43_0_53" title="Screenshot 2026-01-27 at 11.06.13 AM.png"/>
+          <p:cNvPr id="192" name="Google Shape;192;g3bbeee67e43_0_53" title="Screenshot 2026-01-27 at 11.06.13 AM.png"/>
           <p:cNvPicPr preferRelativeResize="0"/>
           <p:nvPr/>
         </p:nvPicPr>
@@ -12717,7 +13041,7 @@
       </p:pic>
       <p:pic>
         <p:nvPicPr>
-          <p:cNvPr id="187" name="Google Shape;187;g3bbeee67e43_0_53" title="Screenshot 2026-01-27 at 11.06.43 AM.png"/>
+          <p:cNvPr id="193" name="Google Shape;193;g3bbeee67e43_0_53" title="Screenshot 2026-01-27 at 11.06.43 AM.png"/>
           <p:cNvPicPr preferRelativeResize="0"/>
           <p:nvPr/>
         </p:nvPicPr>
@@ -12745,7 +13069,7 @@
       </p:pic>
       <p:pic>
         <p:nvPicPr>
-          <p:cNvPr id="188" name="Google Shape;188;g3bbeee67e43_0_53" title="Screenshot 2026-01-27 at 11.12.02 AM.png"/>
+          <p:cNvPr id="194" name="Google Shape;194;g3bbeee67e43_0_53" title="Screenshot 2026-01-27 at 11.12.02 AM.png"/>
           <p:cNvPicPr preferRelativeResize="0"/>
           <p:nvPr/>
         </p:nvPicPr>
@@ -12773,7 +13097,7 @@
       </p:pic>
       <p:pic>
         <p:nvPicPr>
-          <p:cNvPr id="189" name="Google Shape;189;g3bbeee67e43_0_53" title="Screenshot 2026-01-27 at 11.12.43 AM.png"/>
+          <p:cNvPr id="195" name="Google Shape;195;g3bbeee67e43_0_53" title="Screenshot 2026-01-27 at 11.12.43 AM.png"/>
           <p:cNvPicPr preferRelativeResize="0"/>
           <p:nvPr/>
         </p:nvPicPr>
@@ -12801,7 +13125,7 @@
       </p:pic>
       <p:pic>
         <p:nvPicPr>
-          <p:cNvPr id="190" name="Google Shape;190;g3bbeee67e43_0_53" title="Screenshot 2026-01-27 at 11.12.59 AM.png"/>
+          <p:cNvPr id="196" name="Google Shape;196;g3bbeee67e43_0_53" title="Screenshot 2026-01-27 at 11.12.59 AM.png"/>
           <p:cNvPicPr preferRelativeResize="0"/>
           <p:nvPr/>
         </p:nvPicPr>
@@ -12829,7 +13153,7 @@
       </p:pic>
       <p:sp>
         <p:nvSpPr>
-          <p:cNvPr id="191" name="Google Shape;191;g3bbeee67e43_0_53"/>
+          <p:cNvPr id="197" name="Google Shape;197;g3bbeee67e43_0_53"/>
           <p:cNvSpPr/>
           <p:nvPr/>
         </p:nvSpPr>
@@ -12876,7 +13200,7 @@
       </p:sp>
       <p:sp>
         <p:nvSpPr>
-          <p:cNvPr id="192" name="Google Shape;192;g3bbeee67e43_0_53"/>
+          <p:cNvPr id="198" name="Google Shape;198;g3bbeee67e43_0_53"/>
           <p:cNvSpPr/>
           <p:nvPr/>
         </p:nvSpPr>
@@ -12923,10 +13247,10 @@
       </p:sp>
       <p:cxnSp>
         <p:nvCxnSpPr>
-          <p:cNvPr id="193" name="Google Shape;193;g3bbeee67e43_0_53"/>
+          <p:cNvPr id="199" name="Google Shape;199;g3bbeee67e43_0_53"/>
           <p:cNvCxnSpPr>
-            <a:stCxn id="191" idx="3"/>
-            <a:endCxn id="192" idx="0"/>
+            <a:stCxn id="197" idx="3"/>
+            <a:endCxn id="198" idx="0"/>
           </p:cNvCxnSpPr>
           <p:nvPr/>
         </p:nvCxnSpPr>
@@ -12952,7 +13276,7 @@
       </p:cxnSp>
       <p:sp>
         <p:nvSpPr>
-          <p:cNvPr id="194" name="Google Shape;194;g3bbeee67e43_0_53"/>
+          <p:cNvPr id="200" name="Google Shape;200;g3bbeee67e43_0_53"/>
           <p:cNvSpPr/>
           <p:nvPr/>
         </p:nvSpPr>
@@ -12999,7 +13323,7 @@
       </p:sp>
       <p:sp>
         <p:nvSpPr>
-          <p:cNvPr id="195" name="Google Shape;195;g3bbeee67e43_0_53"/>
+          <p:cNvPr id="201" name="Google Shape;201;g3bbeee67e43_0_53"/>
           <p:cNvSpPr/>
           <p:nvPr/>
         </p:nvSpPr>
@@ -13046,7 +13370,7 @@
       </p:sp>
       <p:sp>
         <p:nvSpPr>
-          <p:cNvPr id="196" name="Google Shape;196;g3bbeee67e43_0_53"/>
+          <p:cNvPr id="202" name="Google Shape;202;g3bbeee67e43_0_53"/>
           <p:cNvSpPr/>
           <p:nvPr/>
         </p:nvSpPr>
@@ -13093,9 +13417,9 @@
       </p:sp>
       <p:cxnSp>
         <p:nvCxnSpPr>
-          <p:cNvPr id="197" name="Google Shape;197;g3bbeee67e43_0_53"/>
+          <p:cNvPr id="203" name="Google Shape;203;g3bbeee67e43_0_53"/>
           <p:cNvCxnSpPr>
-            <a:endCxn id="195" idx="2"/>
+            <a:endCxn id="201" idx="2"/>
           </p:cNvCxnSpPr>
           <p:nvPr/>
         </p:nvCxnSpPr>
@@ -13121,10 +13445,10 @@
       </p:cxnSp>
       <p:cxnSp>
         <p:nvCxnSpPr>
-          <p:cNvPr id="198" name="Google Shape;198;g3bbeee67e43_0_53"/>
+          <p:cNvPr id="204" name="Google Shape;204;g3bbeee67e43_0_53"/>
           <p:cNvCxnSpPr>
-            <a:stCxn id="194" idx="3"/>
-            <a:endCxn id="196" idx="2"/>
+            <a:stCxn id="200" idx="3"/>
+            <a:endCxn id="202" idx="2"/>
           </p:cNvCxnSpPr>
           <p:nvPr/>
         </p:nvCxnSpPr>
@@ -13150,7 +13474,7 @@
       </p:cxnSp>
       <p:sp>
         <p:nvSpPr>
-          <p:cNvPr id="199" name="Google Shape;199;g3bbeee67e43_0_53"/>
+          <p:cNvPr id="205" name="Google Shape;205;g3bbeee67e43_0_53"/>
           <p:cNvSpPr/>
           <p:nvPr/>
         </p:nvSpPr>
@@ -13197,7 +13521,7 @@
       </p:sp>
       <p:sp>
         <p:nvSpPr>
-          <p:cNvPr id="200" name="Google Shape;200;g3bbeee67e43_0_53"/>
+          <p:cNvPr id="206" name="Google Shape;206;g3bbeee67e43_0_53"/>
           <p:cNvSpPr/>
           <p:nvPr/>
         </p:nvSpPr>
@@ -13244,10 +13568,10 @@
       </p:sp>
       <p:cxnSp>
         <p:nvCxnSpPr>
-          <p:cNvPr id="201" name="Google Shape;201;g3bbeee67e43_0_53"/>
+          <p:cNvPr id="207" name="Google Shape;207;g3bbeee67e43_0_53"/>
           <p:cNvCxnSpPr>
-            <a:stCxn id="200" idx="0"/>
-            <a:endCxn id="199" idx="1"/>
+            <a:stCxn id="206" idx="0"/>
+            <a:endCxn id="205" idx="1"/>
           </p:cNvCxnSpPr>
           <p:nvPr/>
         </p:nvCxnSpPr>
@@ -13273,10 +13597,10 @@
       </p:cxnSp>
       <p:cxnSp>
         <p:nvCxnSpPr>
-          <p:cNvPr id="202" name="Google Shape;202;g3bbeee67e43_0_53"/>
+          <p:cNvPr id="208" name="Google Shape;208;g3bbeee67e43_0_53"/>
           <p:cNvCxnSpPr>
-            <a:stCxn id="192" idx="0"/>
-            <a:endCxn id="194" idx="1"/>
+            <a:stCxn id="198" idx="0"/>
+            <a:endCxn id="200" idx="1"/>
           </p:cNvCxnSpPr>
           <p:nvPr/>
         </p:nvCxnSpPr>
@@ -13313,7 +13637,7 @@
   <p:cSld>
     <p:spTree>
       <p:nvGrpSpPr>
-        <p:cNvPr id="206" name="Shape 206"/>
+        <p:cNvPr id="212" name="Shape 212"/>
         <p:cNvGrpSpPr/>
         <p:nvPr/>
       </p:nvGrpSpPr>
@@ -13327,7 +13651,7 @@
       </p:grpSpPr>
       <p:sp>
         <p:nvSpPr>
-          <p:cNvPr id="207" name="Google Shape;207;g3bbeee67e43_0_98"/>
+          <p:cNvPr id="213" name="Google Shape;213;g3bbeee67e43_0_98"/>
           <p:cNvSpPr txBox="1"/>
           <p:nvPr>
             <p:ph type="title"/>
@@ -13367,7 +13691,7 @@
       </p:sp>
       <p:sp>
         <p:nvSpPr>
-          <p:cNvPr id="208" name="Google Shape;208;g3bbeee67e43_0_98"/>
+          <p:cNvPr id="214" name="Google Shape;214;g3bbeee67e43_0_98"/>
           <p:cNvSpPr txBox="1"/>
           <p:nvPr>
             <p:ph idx="1" type="body"/>
@@ -13579,7 +13903,7 @@
   <p:cSld>
     <p:spTree>
       <p:nvGrpSpPr>
-        <p:cNvPr id="212" name="Shape 212"/>
+        <p:cNvPr id="218" name="Shape 218"/>
         <p:cNvGrpSpPr/>
         <p:nvPr/>
       </p:nvGrpSpPr>
@@ -13593,7 +13917,7 @@
       </p:grpSpPr>
       <p:sp>
         <p:nvSpPr>
-          <p:cNvPr id="213" name="Google Shape;213;g3bbeee67e43_0_137"/>
+          <p:cNvPr id="219" name="Google Shape;219;g3bbeee67e43_0_137"/>
           <p:cNvSpPr txBox="1"/>
           <p:nvPr>
             <p:ph type="title"/>
@@ -13669,7 +13993,7 @@
       </p:sp>
       <p:sp>
         <p:nvSpPr>
-          <p:cNvPr id="214" name="Google Shape;214;g3bbeee67e43_0_137"/>
+          <p:cNvPr id="220" name="Google Shape;220;g3bbeee67e43_0_137"/>
           <p:cNvSpPr txBox="1"/>
           <p:nvPr>
             <p:ph idx="1" type="body"/>
@@ -13842,7 +14166,7 @@
   <p:cSld>
     <p:spTree>
       <p:nvGrpSpPr>
-        <p:cNvPr id="218" name="Shape 218"/>
+        <p:cNvPr id="224" name="Shape 224"/>
         <p:cNvGrpSpPr/>
         <p:nvPr/>
       </p:nvGrpSpPr>
@@ -13856,7 +14180,7 @@
       </p:grpSpPr>
       <p:sp>
         <p:nvSpPr>
-          <p:cNvPr id="219" name="Google Shape;219;g3bbeee67e43_0_126"/>
+          <p:cNvPr id="225" name="Google Shape;225;g3bbeee67e43_0_126"/>
           <p:cNvSpPr txBox="1"/>
           <p:nvPr>
             <p:ph type="title"/>
@@ -13936,7 +14260,7 @@
       </p:sp>
       <p:sp>
         <p:nvSpPr>
-          <p:cNvPr id="220" name="Google Shape;220;g3bbeee67e43_0_126"/>
+          <p:cNvPr id="226" name="Google Shape;226;g3bbeee67e43_0_126"/>
           <p:cNvSpPr txBox="1"/>
           <p:nvPr>
             <p:ph idx="1" type="body"/>
@@ -14106,7 +14430,7 @@
   <p:cSld>
     <p:spTree>
       <p:nvGrpSpPr>
-        <p:cNvPr id="224" name="Shape 224"/>
+        <p:cNvPr id="230" name="Shape 230"/>
         <p:cNvGrpSpPr/>
         <p:nvPr/>
       </p:nvGrpSpPr>
@@ -14120,7 +14444,7 @@
       </p:grpSpPr>
       <p:sp>
         <p:nvSpPr>
-          <p:cNvPr id="225" name="Google Shape;225;g3bbeee67e43_0_132"/>
+          <p:cNvPr id="231" name="Google Shape;231;g3bbeee67e43_0_132"/>
           <p:cNvSpPr txBox="1"/>
           <p:nvPr>
             <p:ph type="title"/>
@@ -14196,7 +14520,7 @@
       </p:sp>
       <p:sp>
         <p:nvSpPr>
-          <p:cNvPr id="226" name="Google Shape;226;g3bbeee67e43_0_132"/>
+          <p:cNvPr id="232" name="Google Shape;232;g3bbeee67e43_0_132"/>
           <p:cNvSpPr txBox="1"/>
           <p:nvPr>
             <p:ph idx="1" type="body"/>
@@ -14341,7 +14665,7 @@
   <p:cSld>
     <p:spTree>
       <p:nvGrpSpPr>
-        <p:cNvPr id="230" name="Shape 230"/>
+        <p:cNvPr id="236" name="Shape 236"/>
         <p:cNvGrpSpPr/>
         <p:nvPr/>
       </p:nvGrpSpPr>
@@ -14355,7 +14679,7 @@
       </p:grpSpPr>
       <p:sp>
         <p:nvSpPr>
-          <p:cNvPr id="231" name="Google Shape;231;g3bbeee67e43_0_147"/>
+          <p:cNvPr id="237" name="Google Shape;237;g3bbeee67e43_0_147"/>
           <p:cNvSpPr txBox="1"/>
           <p:nvPr>
             <p:ph type="title"/>
@@ -14439,7 +14763,7 @@
       </p:sp>
       <p:sp>
         <p:nvSpPr>
-          <p:cNvPr id="232" name="Google Shape;232;g3bbeee67e43_0_147"/>
+          <p:cNvPr id="238" name="Google Shape;238;g3bbeee67e43_0_147"/>
           <p:cNvSpPr txBox="1"/>
           <p:nvPr>
             <p:ph idx="1" type="body"/>
@@ -14733,7 +15057,7 @@
   <p:cSld>
     <p:spTree>
       <p:nvGrpSpPr>
-        <p:cNvPr id="236" name="Shape 236"/>
+        <p:cNvPr id="242" name="Shape 242"/>
         <p:cNvGrpSpPr/>
         <p:nvPr/>
       </p:nvGrpSpPr>
@@ -14747,7 +15071,7 @@
       </p:grpSpPr>
       <p:sp>
         <p:nvSpPr>
-          <p:cNvPr id="237" name="Google Shape;237;g3bbeee67e43_0_142"/>
+          <p:cNvPr id="243" name="Google Shape;243;g3bbeee67e43_0_142"/>
           <p:cNvSpPr txBox="1"/>
           <p:nvPr>
             <p:ph type="title"/>
@@ -14831,7 +15155,7 @@
       </p:sp>
       <p:sp>
         <p:nvSpPr>
-          <p:cNvPr id="238" name="Google Shape;238;g3bbeee67e43_0_142"/>
+          <p:cNvPr id="244" name="Google Shape;244;g3bbeee67e43_0_142"/>
           <p:cNvSpPr txBox="1"/>
           <p:nvPr>
             <p:ph idx="1" type="body"/>
@@ -14981,7 +15305,7 @@
   <p:cSld>
     <p:spTree>
       <p:nvGrpSpPr>
-        <p:cNvPr id="242" name="Shape 242"/>
+        <p:cNvPr id="248" name="Shape 248"/>
         <p:cNvGrpSpPr/>
         <p:nvPr/>
       </p:nvGrpSpPr>
@@ -14995,7 +15319,7 @@
       </p:grpSpPr>
       <p:sp>
         <p:nvSpPr>
-          <p:cNvPr id="243" name="Google Shape;243;g3bbeee67e43_0_93"/>
+          <p:cNvPr id="249" name="Google Shape;249;g3bbeee67e43_0_93"/>
           <p:cNvSpPr txBox="1"/>
           <p:nvPr>
             <p:ph type="title"/>
@@ -15035,7 +15359,7 @@
       </p:sp>
       <p:sp>
         <p:nvSpPr>
-          <p:cNvPr id="244" name="Google Shape;244;g3bbeee67e43_0_93"/>
+          <p:cNvPr id="250" name="Google Shape;250;g3bbeee67e43_0_93"/>
           <p:cNvSpPr txBox="1"/>
           <p:nvPr>
             <p:ph idx="1" type="body"/>

</xml_diff>